<commit_message>
Offres : plus d'aide en ligne, de délai de réponse ni d'engagement de disponibilité
Retirés à la demande de Julien. Les deux derniers promettaient ce que les
CGV (8.2, 8.3) écartent. Le deck commercial lit à nouveau les points tels
quels, sans filtre.

Co-Authored-By: Claude Opus 5 <noreply@anthropic.com>
</commit_message>
<xml_diff>
--- a/docs/entreprise/deck/Quantinvo-commercial-marque.pptx
+++ b/docs/entreprise/deck/Quantinvo-commercial-marque.pptx
@@ -5184,6 +5184,290 @@
             </a:r>
             <a:endParaRPr lang="en-US" sz="950" dirty="0"/>
           </a:p>
+        </p:txBody>
+      </p:sp>
+      <p:sp>
+        <p:nvSpPr>
+          <p:cNvPr id="16" name="Shape 13"/>
+          <p:cNvSpPr/>
+          <p:nvPr/>
+        </p:nvSpPr>
+        <p:spPr>
+          <a:xfrm>
+            <a:off x="4392168" y="2194560"/>
+            <a:ext cx="3404616" cy="3429000"/>
+          </a:xfrm>
+          <a:prstGeom prst="roundRect">
+            <a:avLst>
+              <a:gd name="adj" fmla="val 1074"/>
+            </a:avLst>
+          </a:prstGeom>
+          <a:solidFill>
+            <a:srgbClr val="E7EDE9"/>
+          </a:solidFill>
+          <a:ln w="15875">
+            <a:solidFill>
+              <a:srgbClr val="1E4D3B"/>
+            </a:solidFill>
+            <a:prstDash val="solid"/>
+          </a:ln>
+        </p:spPr>
+      </p:sp>
+      <p:sp>
+        <p:nvSpPr>
+          <p:cNvPr id="17" name="Text 14"/>
+          <p:cNvSpPr/>
+          <p:nvPr/>
+        </p:nvSpPr>
+        <p:spPr>
+          <a:xfrm>
+            <a:off x="4648200" y="2414016"/>
+            <a:ext cx="2892552" cy="347472"/>
+          </a:xfrm>
+          <a:prstGeom prst="rect">
+            <a:avLst/>
+          </a:prstGeom>
+          <a:noFill/>
+          <a:ln/>
+        </p:spPr>
+        <p:txBody>
+          <a:bodyPr wrap="square" lIns="0" tIns="0" rIns="0" bIns="0" rtlCol="0" anchor="t"/>
+          <a:lstStyle/>
+          <a:p>
+            <a:pPr indent="0" marL="0">
+              <a:buNone/>
+            </a:pPr>
+            <a:r>
+              <a:rPr lang="en-US" sz="1800" b="1" dirty="0">
+                <a:solidFill>
+                  <a:srgbClr val="14181A"/>
+                </a:solidFill>
+                <a:latin typeface="Archivo" pitchFamily="34" charset="0"/>
+                <a:ea typeface="Archivo" pitchFamily="34" charset="-122"/>
+                <a:cs typeface="Archivo" pitchFamily="34" charset="-120"/>
+              </a:rPr>
+              <a:t>Advanced</a:t>
+            </a:r>
+            <a:endParaRPr lang="en-US" sz="1800" dirty="0"/>
+          </a:p>
+        </p:txBody>
+      </p:sp>
+      <p:sp>
+        <p:nvSpPr>
+          <p:cNvPr id="18" name="Text 15"/>
+          <p:cNvSpPr/>
+          <p:nvPr/>
+        </p:nvSpPr>
+        <p:spPr>
+          <a:xfrm>
+            <a:off x="4648200" y="2798064"/>
+            <a:ext cx="2892552" cy="256032"/>
+          </a:xfrm>
+          <a:prstGeom prst="rect">
+            <a:avLst/>
+          </a:prstGeom>
+          <a:noFill/>
+          <a:ln/>
+        </p:spPr>
+        <p:txBody>
+          <a:bodyPr wrap="square" lIns="0" tIns="0" rIns="0" bIns="0" rtlCol="0" anchor="t"/>
+          <a:lstStyle/>
+          <a:p>
+            <a:pPr indent="0" marL="0">
+              <a:buNone/>
+            </a:pPr>
+            <a:r>
+              <a:rPr lang="en-US" sz="1100" b="1" dirty="0">
+                <a:solidFill>
+                  <a:srgbClr val="14181A"/>
+                </a:solidFill>
+                <a:latin typeface="Public Sans" pitchFamily="34" charset="0"/>
+                <a:ea typeface="Public Sans" pitchFamily="34" charset="-122"/>
+                <a:cs typeface="Public Sans" pitchFamily="34" charset="-120"/>
+              </a:rPr>
+              <a:t>Jusqu’à 20 appareils</a:t>
+            </a:r>
+            <a:endParaRPr lang="en-US" sz="1100" dirty="0"/>
+          </a:p>
+        </p:txBody>
+      </p:sp>
+      <p:sp>
+        <p:nvSpPr>
+          <p:cNvPr id="19" name="Text 16"/>
+          <p:cNvSpPr/>
+          <p:nvPr/>
+        </p:nvSpPr>
+        <p:spPr>
+          <a:xfrm>
+            <a:off x="4648200" y="3072384"/>
+            <a:ext cx="3075432" cy="365760"/>
+          </a:xfrm>
+          <a:prstGeom prst="rect">
+            <a:avLst/>
+          </a:prstGeom>
+          <a:noFill/>
+          <a:ln/>
+        </p:spPr>
+        <p:txBody>
+          <a:bodyPr wrap="square" lIns="0" tIns="0" rIns="0" bIns="0" rtlCol="0" anchor="t"/>
+          <a:lstStyle/>
+          <a:p>
+            <a:pPr indent="0" marL="0">
+              <a:lnSpc>
+                <a:spcPct val="112000"/>
+              </a:lnSpc>
+              <a:buNone/>
+            </a:pPr>
+            <a:r>
+              <a:rPr lang="en-US" sz="950" dirty="0">
+                <a:solidFill>
+                  <a:srgbClr val="575F5C"/>
+                </a:solidFill>
+                <a:latin typeface="Public Sans" pitchFamily="34" charset="0"/>
+                <a:ea typeface="Public Sans" pitchFamily="34" charset="-122"/>
+                <a:cs typeface="Public Sans" pitchFamily="34" charset="-120"/>
+              </a:rPr>
+              <a:t>Vous montez une équipe le jour de l’inventaire.</a:t>
+            </a:r>
+            <a:endParaRPr lang="en-US" sz="950" dirty="0"/>
+          </a:p>
+        </p:txBody>
+      </p:sp>
+      <p:sp>
+        <p:nvSpPr>
+          <p:cNvPr id="20" name="Text 17"/>
+          <p:cNvSpPr/>
+          <p:nvPr/>
+        </p:nvSpPr>
+        <p:spPr>
+          <a:xfrm>
+            <a:off x="4648200" y="3474720"/>
+            <a:ext cx="2892552" cy="457200"/>
+          </a:xfrm>
+          <a:prstGeom prst="rect">
+            <a:avLst/>
+          </a:prstGeom>
+          <a:noFill/>
+          <a:ln/>
+        </p:spPr>
+        <p:txBody>
+          <a:bodyPr wrap="square" lIns="0" tIns="0" rIns="0" bIns="0" rtlCol="0" anchor="b"/>
+          <a:lstStyle/>
+          <a:p>
+            <a:pPr indent="0" marL="0">
+              <a:buNone/>
+            </a:pPr>
+            <a:r>
+              <a:rPr lang="en-US" sz="2600" b="1" dirty="0">
+                <a:solidFill>
+                  <a:srgbClr val="14181A"/>
+                </a:solidFill>
+                <a:latin typeface="Archivo" pitchFamily="34" charset="0"/>
+                <a:ea typeface="Archivo" pitchFamily="34" charset="-122"/>
+                <a:cs typeface="Archivo" pitchFamily="34" charset="-120"/>
+              </a:rPr>
+              <a:t>310 €</a:t>
+            </a:r>
+            <a:pPr indent="0" marL="0">
+              <a:buNone/>
+            </a:pPr>
+            <a:r>
+              <a:rPr lang="en-US" sz="1050" dirty="0">
+                <a:solidFill>
+                  <a:srgbClr val="575F5C"/>
+                </a:solidFill>
+                <a:latin typeface="Public Sans" pitchFamily="34" charset="0"/>
+                <a:ea typeface="Public Sans" pitchFamily="34" charset="-122"/>
+                <a:cs typeface="Public Sans" pitchFamily="34" charset="-120"/>
+              </a:rPr>
+              <a:t> / mois</a:t>
+            </a:r>
+            <a:endParaRPr lang="en-US" sz="2600" dirty="0"/>
+          </a:p>
+        </p:txBody>
+      </p:sp>
+      <p:sp>
+        <p:nvSpPr>
+          <p:cNvPr id="21" name="Text 18"/>
+          <p:cNvSpPr/>
+          <p:nvPr/>
+        </p:nvSpPr>
+        <p:spPr>
+          <a:xfrm>
+            <a:off x="4648200" y="3950208"/>
+            <a:ext cx="2892552" cy="237744"/>
+          </a:xfrm>
+          <a:prstGeom prst="rect">
+            <a:avLst/>
+          </a:prstGeom>
+          <a:noFill/>
+          <a:ln/>
+        </p:spPr>
+        <p:txBody>
+          <a:bodyPr wrap="square" lIns="0" tIns="0" rIns="0" bIns="0" rtlCol="0" anchor="t"/>
+          <a:lstStyle/>
+          <a:p>
+            <a:pPr indent="0" marL="0">
+              <a:buNone/>
+            </a:pPr>
+            <a:r>
+              <a:rPr lang="en-US" sz="950" dirty="0">
+                <a:solidFill>
+                  <a:srgbClr val="575F5C"/>
+                </a:solidFill>
+                <a:latin typeface="Public Sans" pitchFamily="34" charset="0"/>
+                <a:ea typeface="Public Sans" pitchFamily="34" charset="-122"/>
+                <a:cs typeface="Public Sans" pitchFamily="34" charset="-120"/>
+              </a:rPr>
+              <a:t>ou 3 300 € à l’année, soit 420 € de moins</a:t>
+            </a:r>
+            <a:endParaRPr lang="en-US" sz="950" dirty="0"/>
+          </a:p>
+        </p:txBody>
+      </p:sp>
+      <p:sp>
+        <p:nvSpPr>
+          <p:cNvPr id="22" name="Shape 19"/>
+          <p:cNvSpPr/>
+          <p:nvPr/>
+        </p:nvSpPr>
+        <p:spPr>
+          <a:xfrm>
+            <a:off x="4648200" y="4242816"/>
+            <a:ext cx="2892552" cy="0"/>
+          </a:xfrm>
+          <a:prstGeom prst="line">
+            <a:avLst/>
+          </a:prstGeom>
+          <a:noFill/>
+          <a:ln w="9525">
+            <a:solidFill>
+              <a:srgbClr val="E2E5E1"/>
+            </a:solidFill>
+            <a:prstDash val="solid"/>
+          </a:ln>
+        </p:spPr>
+      </p:sp>
+      <p:sp>
+        <p:nvSpPr>
+          <p:cNvPr id="23" name="Text 20"/>
+          <p:cNvSpPr/>
+          <p:nvPr/>
+        </p:nvSpPr>
+        <p:spPr>
+          <a:xfrm>
+            <a:off x="4648200" y="4352544"/>
+            <a:ext cx="2892552" cy="1143000"/>
+          </a:xfrm>
+          <a:prstGeom prst="rect">
+            <a:avLst/>
+          </a:prstGeom>
+          <a:noFill/>
+          <a:ln/>
+        </p:spPr>
+        <p:txBody>
+          <a:bodyPr wrap="square" lIns="0" tIns="0" rIns="0" bIns="0" rtlCol="0" anchor="t"/>
+          <a:lstStyle/>
           <a:p>
             <a:pPr marL="152400" indent="-152400">
               <a:lnSpc>
@@ -5204,294 +5488,10 @@
                 <a:ea typeface="Public Sans" pitchFamily="34" charset="-122"/>
                 <a:cs typeface="Public Sans" pitchFamily="34" charset="-120"/>
               </a:rPr>
-              <a:t>Aide en ligne</a:t>
+              <a:t>Tout ce que contient Essential</a:t>
             </a:r>
             <a:endParaRPr lang="en-US" sz="950" dirty="0"/>
           </a:p>
-        </p:txBody>
-      </p:sp>
-      <p:sp>
-        <p:nvSpPr>
-          <p:cNvPr id="16" name="Shape 13"/>
-          <p:cNvSpPr/>
-          <p:nvPr/>
-        </p:nvSpPr>
-        <p:spPr>
-          <a:xfrm>
-            <a:off x="4392168" y="2194560"/>
-            <a:ext cx="3404616" cy="3429000"/>
-          </a:xfrm>
-          <a:prstGeom prst="roundRect">
-            <a:avLst>
-              <a:gd name="adj" fmla="val 1074"/>
-            </a:avLst>
-          </a:prstGeom>
-          <a:solidFill>
-            <a:srgbClr val="E7EDE9"/>
-          </a:solidFill>
-          <a:ln w="15875">
-            <a:solidFill>
-              <a:srgbClr val="1E4D3B"/>
-            </a:solidFill>
-            <a:prstDash val="solid"/>
-          </a:ln>
-        </p:spPr>
-      </p:sp>
-      <p:sp>
-        <p:nvSpPr>
-          <p:cNvPr id="17" name="Text 14"/>
-          <p:cNvSpPr/>
-          <p:nvPr/>
-        </p:nvSpPr>
-        <p:spPr>
-          <a:xfrm>
-            <a:off x="4648200" y="2414016"/>
-            <a:ext cx="2892552" cy="347472"/>
-          </a:xfrm>
-          <a:prstGeom prst="rect">
-            <a:avLst/>
-          </a:prstGeom>
-          <a:noFill/>
-          <a:ln/>
-        </p:spPr>
-        <p:txBody>
-          <a:bodyPr wrap="square" lIns="0" tIns="0" rIns="0" bIns="0" rtlCol="0" anchor="t"/>
-          <a:lstStyle/>
-          <a:p>
-            <a:pPr indent="0" marL="0">
-              <a:buNone/>
-            </a:pPr>
-            <a:r>
-              <a:rPr lang="en-US" sz="1800" b="1" dirty="0">
-                <a:solidFill>
-                  <a:srgbClr val="14181A"/>
-                </a:solidFill>
-                <a:latin typeface="Archivo" pitchFamily="34" charset="0"/>
-                <a:ea typeface="Archivo" pitchFamily="34" charset="-122"/>
-                <a:cs typeface="Archivo" pitchFamily="34" charset="-120"/>
-              </a:rPr>
-              <a:t>Advanced</a:t>
-            </a:r>
-            <a:endParaRPr lang="en-US" sz="1800" dirty="0"/>
-          </a:p>
-        </p:txBody>
-      </p:sp>
-      <p:sp>
-        <p:nvSpPr>
-          <p:cNvPr id="18" name="Text 15"/>
-          <p:cNvSpPr/>
-          <p:nvPr/>
-        </p:nvSpPr>
-        <p:spPr>
-          <a:xfrm>
-            <a:off x="4648200" y="2798064"/>
-            <a:ext cx="2892552" cy="256032"/>
-          </a:xfrm>
-          <a:prstGeom prst="rect">
-            <a:avLst/>
-          </a:prstGeom>
-          <a:noFill/>
-          <a:ln/>
-        </p:spPr>
-        <p:txBody>
-          <a:bodyPr wrap="square" lIns="0" tIns="0" rIns="0" bIns="0" rtlCol="0" anchor="t"/>
-          <a:lstStyle/>
-          <a:p>
-            <a:pPr indent="0" marL="0">
-              <a:buNone/>
-            </a:pPr>
-            <a:r>
-              <a:rPr lang="en-US" sz="1100" b="1" dirty="0">
-                <a:solidFill>
-                  <a:srgbClr val="14181A"/>
-                </a:solidFill>
-                <a:latin typeface="Public Sans" pitchFamily="34" charset="0"/>
-                <a:ea typeface="Public Sans" pitchFamily="34" charset="-122"/>
-                <a:cs typeface="Public Sans" pitchFamily="34" charset="-120"/>
-              </a:rPr>
-              <a:t>Jusqu’à 20 appareils</a:t>
-            </a:r>
-            <a:endParaRPr lang="en-US" sz="1100" dirty="0"/>
-          </a:p>
-        </p:txBody>
-      </p:sp>
-      <p:sp>
-        <p:nvSpPr>
-          <p:cNvPr id="19" name="Text 16"/>
-          <p:cNvSpPr/>
-          <p:nvPr/>
-        </p:nvSpPr>
-        <p:spPr>
-          <a:xfrm>
-            <a:off x="4648200" y="3072384"/>
-            <a:ext cx="3075432" cy="365760"/>
-          </a:xfrm>
-          <a:prstGeom prst="rect">
-            <a:avLst/>
-          </a:prstGeom>
-          <a:noFill/>
-          <a:ln/>
-        </p:spPr>
-        <p:txBody>
-          <a:bodyPr wrap="square" lIns="0" tIns="0" rIns="0" bIns="0" rtlCol="0" anchor="t"/>
-          <a:lstStyle/>
-          <a:p>
-            <a:pPr indent="0" marL="0">
-              <a:lnSpc>
-                <a:spcPct val="112000"/>
-              </a:lnSpc>
-              <a:buNone/>
-            </a:pPr>
-            <a:r>
-              <a:rPr lang="en-US" sz="950" dirty="0">
-                <a:solidFill>
-                  <a:srgbClr val="575F5C"/>
-                </a:solidFill>
-                <a:latin typeface="Public Sans" pitchFamily="34" charset="0"/>
-                <a:ea typeface="Public Sans" pitchFamily="34" charset="-122"/>
-                <a:cs typeface="Public Sans" pitchFamily="34" charset="-120"/>
-              </a:rPr>
-              <a:t>Vous montez une équipe le jour de l’inventaire.</a:t>
-            </a:r>
-            <a:endParaRPr lang="en-US" sz="950" dirty="0"/>
-          </a:p>
-        </p:txBody>
-      </p:sp>
-      <p:sp>
-        <p:nvSpPr>
-          <p:cNvPr id="20" name="Text 17"/>
-          <p:cNvSpPr/>
-          <p:nvPr/>
-        </p:nvSpPr>
-        <p:spPr>
-          <a:xfrm>
-            <a:off x="4648200" y="3474720"/>
-            <a:ext cx="2892552" cy="457200"/>
-          </a:xfrm>
-          <a:prstGeom prst="rect">
-            <a:avLst/>
-          </a:prstGeom>
-          <a:noFill/>
-          <a:ln/>
-        </p:spPr>
-        <p:txBody>
-          <a:bodyPr wrap="square" lIns="0" tIns="0" rIns="0" bIns="0" rtlCol="0" anchor="b"/>
-          <a:lstStyle/>
-          <a:p>
-            <a:pPr indent="0" marL="0">
-              <a:buNone/>
-            </a:pPr>
-            <a:r>
-              <a:rPr lang="en-US" sz="2600" b="1" dirty="0">
-                <a:solidFill>
-                  <a:srgbClr val="14181A"/>
-                </a:solidFill>
-                <a:latin typeface="Archivo" pitchFamily="34" charset="0"/>
-                <a:ea typeface="Archivo" pitchFamily="34" charset="-122"/>
-                <a:cs typeface="Archivo" pitchFamily="34" charset="-120"/>
-              </a:rPr>
-              <a:t>310 €</a:t>
-            </a:r>
-            <a:pPr indent="0" marL="0">
-              <a:buNone/>
-            </a:pPr>
-            <a:r>
-              <a:rPr lang="en-US" sz="1050" dirty="0">
-                <a:solidFill>
-                  <a:srgbClr val="575F5C"/>
-                </a:solidFill>
-                <a:latin typeface="Public Sans" pitchFamily="34" charset="0"/>
-                <a:ea typeface="Public Sans" pitchFamily="34" charset="-122"/>
-                <a:cs typeface="Public Sans" pitchFamily="34" charset="-120"/>
-              </a:rPr>
-              <a:t> / mois</a:t>
-            </a:r>
-            <a:endParaRPr lang="en-US" sz="2600" dirty="0"/>
-          </a:p>
-        </p:txBody>
-      </p:sp>
-      <p:sp>
-        <p:nvSpPr>
-          <p:cNvPr id="21" name="Text 18"/>
-          <p:cNvSpPr/>
-          <p:nvPr/>
-        </p:nvSpPr>
-        <p:spPr>
-          <a:xfrm>
-            <a:off x="4648200" y="3950208"/>
-            <a:ext cx="2892552" cy="237744"/>
-          </a:xfrm>
-          <a:prstGeom prst="rect">
-            <a:avLst/>
-          </a:prstGeom>
-          <a:noFill/>
-          <a:ln/>
-        </p:spPr>
-        <p:txBody>
-          <a:bodyPr wrap="square" lIns="0" tIns="0" rIns="0" bIns="0" rtlCol="0" anchor="t"/>
-          <a:lstStyle/>
-          <a:p>
-            <a:pPr indent="0" marL="0">
-              <a:buNone/>
-            </a:pPr>
-            <a:r>
-              <a:rPr lang="en-US" sz="950" dirty="0">
-                <a:solidFill>
-                  <a:srgbClr val="575F5C"/>
-                </a:solidFill>
-                <a:latin typeface="Public Sans" pitchFamily="34" charset="0"/>
-                <a:ea typeface="Public Sans" pitchFamily="34" charset="-122"/>
-                <a:cs typeface="Public Sans" pitchFamily="34" charset="-120"/>
-              </a:rPr>
-              <a:t>ou 3 300 € à l’année, soit 420 € de moins</a:t>
-            </a:r>
-            <a:endParaRPr lang="en-US" sz="950" dirty="0"/>
-          </a:p>
-        </p:txBody>
-      </p:sp>
-      <p:sp>
-        <p:nvSpPr>
-          <p:cNvPr id="22" name="Shape 19"/>
-          <p:cNvSpPr/>
-          <p:nvPr/>
-        </p:nvSpPr>
-        <p:spPr>
-          <a:xfrm>
-            <a:off x="4648200" y="4242816"/>
-            <a:ext cx="2892552" cy="0"/>
-          </a:xfrm>
-          <a:prstGeom prst="line">
-            <a:avLst/>
-          </a:prstGeom>
-          <a:noFill/>
-          <a:ln w="9525">
-            <a:solidFill>
-              <a:srgbClr val="E2E5E1"/>
-            </a:solidFill>
-            <a:prstDash val="solid"/>
-          </a:ln>
-        </p:spPr>
-      </p:sp>
-      <p:sp>
-        <p:nvSpPr>
-          <p:cNvPr id="23" name="Text 20"/>
-          <p:cNvSpPr/>
-          <p:nvPr/>
-        </p:nvSpPr>
-        <p:spPr>
-          <a:xfrm>
-            <a:off x="4648200" y="4352544"/>
-            <a:ext cx="2892552" cy="1143000"/>
-          </a:xfrm>
-          <a:prstGeom prst="rect">
-            <a:avLst/>
-          </a:prstGeom>
-          <a:noFill/>
-          <a:ln/>
-        </p:spPr>
-        <p:txBody>
-          <a:bodyPr wrap="square" lIns="0" tIns="0" rIns="0" bIns="0" rtlCol="0" anchor="t"/>
-          <a:lstStyle/>
           <a:p>
             <a:pPr marL="152400" indent="-152400">
               <a:lnSpc>
@@ -5512,7 +5512,7 @@
                 <a:ea typeface="Public Sans" pitchFamily="34" charset="-122"/>
                 <a:cs typeface="Public Sans" pitchFamily="34" charset="-120"/>
               </a:rPr>
-              <a:t>Tout ce que contient Essential</a:t>
+              <a:t>Équipe, rôles et supervision</a:t>
             </a:r>
             <a:endParaRPr lang="en-US" sz="950" dirty="0"/>
           </a:p>
@@ -5536,7 +5536,7 @@
                 <a:ea typeface="Public Sans" pitchFamily="34" charset="-122"/>
                 <a:cs typeface="Public Sans" pitchFamily="34" charset="-120"/>
               </a:rPr>
-              <a:t>Équipe, rôles et supervision</a:t>
+              <a:t>Balises imprimées et zones de comptage</a:t>
             </a:r>
             <a:endParaRPr lang="en-US" sz="950" dirty="0"/>
           </a:p>
@@ -5560,55 +5560,7 @@
                 <a:ea typeface="Public Sans" pitchFamily="34" charset="-122"/>
                 <a:cs typeface="Public Sans" pitchFamily="34" charset="-120"/>
               </a:rPr>
-              <a:t>Balises imprimées et zones de comptage</a:t>
-            </a:r>
-            <a:endParaRPr lang="en-US" sz="950" dirty="0"/>
-          </a:p>
-          <a:p>
-            <a:pPr marL="152400" indent="-152400">
-              <a:lnSpc>
-                <a:spcPct val="108000"/>
-              </a:lnSpc>
-              <a:spcAft>
-                <a:spcPts val="400"/>
-              </a:spcAft>
-              <a:buSzPct val="100000"/>
-              <a:buChar char="–"/>
-            </a:pPr>
-            <a:r>
-              <a:rPr lang="en-US" sz="950" dirty="0">
-                <a:solidFill>
-                  <a:srgbClr val="3A423F"/>
-                </a:solidFill>
-                <a:latin typeface="Public Sans" pitchFamily="34" charset="0"/>
-                <a:ea typeface="Public Sans" pitchFamily="34" charset="-122"/>
-                <a:cs typeface="Public Sans" pitchFamily="34" charset="-120"/>
-              </a:rPr>
               <a:t>Suivi de l’avancement en direct</a:t>
-            </a:r>
-            <a:endParaRPr lang="en-US" sz="950" dirty="0"/>
-          </a:p>
-          <a:p>
-            <a:pPr marL="152400" indent="-152400">
-              <a:lnSpc>
-                <a:spcPct val="108000"/>
-              </a:lnSpc>
-              <a:spcAft>
-                <a:spcPts val="400"/>
-              </a:spcAft>
-              <a:buSzPct val="100000"/>
-              <a:buChar char="–"/>
-            </a:pPr>
-            <a:r>
-              <a:rPr lang="en-US" sz="950" dirty="0">
-                <a:solidFill>
-                  <a:srgbClr val="3A423F"/>
-                </a:solidFill>
-                <a:latin typeface="Public Sans" pitchFamily="34" charset="0"/>
-                <a:ea typeface="Public Sans" pitchFamily="34" charset="-122"/>
-                <a:cs typeface="Public Sans" pitchFamily="34" charset="-120"/>
-              </a:rPr>
-              <a:t>Assistance par e-mail, les jours ouvrés</a:t>
             </a:r>
             <a:endParaRPr lang="en-US" sz="950" dirty="0"/>
           </a:p>

</xml_diff>